<commit_message>
Alter to synthetic data and to relative folder links. Improve SPSS data summary
</commit_message>
<xml_diff>
--- a/Example PowerPoint from functions.pptx
+++ b/Example PowerPoint from functions.pptx
@@ -125,7 +125,7 @@
 </p:presentation>
 </file>
 
-<file path=ppt/charts/chart2ba757663619.xml><?xml version="1.0" encoding="utf-8"?>
+<file path=ppt/charts/chart50f418638aa5.xml><?xml version="1.0" encoding="utf-8"?>
 <c:chartSpace xmlns:c="http://schemas.openxmlformats.org/drawingml/2006/chart" xmlns:a="http://schemas.openxmlformats.org/drawingml/2006/main" xmlns:r="http://schemas.openxmlformats.org/officeDocument/2006/relationships">
   <c:date1904 val="0"/>
   <c:lang val="fr-FR"/>
@@ -502,7 +502,7 @@
 </c:chartSpace>
 </file>
 
-<file path=ppt/charts/chart2ba779503794.xml><?xml version="1.0" encoding="utf-8"?>
+<file path=ppt/charts/chart50f44b021379.xml><?xml version="1.0" encoding="utf-8"?>
 <c:chartSpace xmlns:c="http://schemas.openxmlformats.org/drawingml/2006/chart" xmlns:a="http://schemas.openxmlformats.org/drawingml/2006/main" xmlns:r="http://schemas.openxmlformats.org/officeDocument/2006/relationships">
   <c:date1904 val="0"/>
   <c:lang val="fr-FR"/>

</xml_diff>

<commit_message>
minor template tweak for slides
</commit_message>
<xml_diff>
--- a/Example PowerPoint from functions.pptx
+++ b/Example PowerPoint from functions.pptx
@@ -125,7 +125,7 @@
 </p:presentation>
 </file>
 
-<file path=ppt/charts/chart37e232172030.xml><?xml version="1.0" encoding="utf-8"?>
+<file path=ppt/charts/chart389a26aa860.xml><?xml version="1.0" encoding="utf-8"?>
 <c:chartSpace xmlns:c="http://schemas.openxmlformats.org/drawingml/2006/chart" xmlns:a="http://schemas.openxmlformats.org/drawingml/2006/main" xmlns:r="http://schemas.openxmlformats.org/officeDocument/2006/relationships">
   <c:date1904 val="0"/>
   <c:lang val="fr-FR"/>
@@ -502,7 +502,7 @@
 </c:chartSpace>
 </file>
 
-<file path=ppt/charts/chart37e26572c10e.xml><?xml version="1.0" encoding="utf-8"?>
+<file path=ppt/charts/chart389a72d4c1e7.xml><?xml version="1.0" encoding="utf-8"?>
 <c:chartSpace xmlns:c="http://schemas.openxmlformats.org/drawingml/2006/chart" xmlns:a="http://schemas.openxmlformats.org/drawingml/2006/main" xmlns:r="http://schemas.openxmlformats.org/officeDocument/2006/relationships">
   <c:date1904 val="0"/>
   <c:lang val="fr-FR"/>
@@ -973,7 +973,7 @@
           <a:p>
             <a:fld id="{D064416C-77FE-564C-A2DA-473082896773}" type="datetimeFigureOut">
               <a:rPr lang="en-US" smtClean="0"/>
-              <a:t>4/12/26</a:t>
+              <a:t>6/17/26</a:t>
             </a:fld>
             <a:endParaRPr lang="en-US"/>
           </a:p>
@@ -1805,7 +1805,7 @@
         <p:nvSpPr>
           <p:cNvPr id="3" name="Content Placeholder 2"/>
           <p:cNvSpPr>
-            <a:spLocks/>
+            <a:spLocks noGrp="1"/>
           </p:cNvSpPr>
           <p:nvPr>
             <p:ph type="body" idx="1"/>
@@ -2285,13 +2285,13 @@
         </p:nvCxnSpPr>
         <p:spPr>
           <a:xfrm>
-            <a:off x="4508500" y="1399769"/>
+            <a:off x="4508500" y="1415671"/>
             <a:ext cx="0" cy="4955400"/>
           </a:xfrm>
           <a:prstGeom prst="line">
             <a:avLst/>
           </a:prstGeom>
-          <a:ln w="25400">
+          <a:ln w="12700">
             <a:solidFill>
               <a:srgbClr val="000000"/>
             </a:solidFill>

</xml_diff>

<commit_message>
Rewire export_to_powerpoint.qmd onto the deck package
The .qmd no longer defines the builders inline and deparses them to
Scripts/ppt_functions/; it now library(deck) and calls them. Regenerates
Example PowerPoint from functions.pptx with byte-for-byte equivalent
content (same 8 slides, layouts, text and tables).

Also: order footer before header in add_divider_slide() so shape order in
the output matches the previous inline function.

Co-Authored-By: Claude Sonnet 5 <noreply@anthropic.com>
</commit_message>
<xml_diff>
--- a/Example PowerPoint from functions.pptx
+++ b/Example PowerPoint from functions.pptx
@@ -125,7 +125,7 @@
 </p:presentation>
 </file>
 
-<file path=ppt/charts/chart389a26aa860.xml><?xml version="1.0" encoding="utf-8"?>
+<file path=ppt/charts/chart2b3f6ff6a6ef.xml><?xml version="1.0" encoding="utf-8"?>
 <c:chartSpace xmlns:c="http://schemas.openxmlformats.org/drawingml/2006/chart" xmlns:a="http://schemas.openxmlformats.org/drawingml/2006/main" xmlns:r="http://schemas.openxmlformats.org/officeDocument/2006/relationships">
   <c:date1904 val="0"/>
   <c:lang val="fr-FR"/>
@@ -502,7 +502,7 @@
 </c:chartSpace>
 </file>
 
-<file path=ppt/charts/chart389a72d4c1e7.xml><?xml version="1.0" encoding="utf-8"?>
+<file path=ppt/charts/chart2b3f78481caa.xml><?xml version="1.0" encoding="utf-8"?>
 <c:chartSpace xmlns:c="http://schemas.openxmlformats.org/drawingml/2006/chart" xmlns:a="http://schemas.openxmlformats.org/drawingml/2006/main" xmlns:r="http://schemas.openxmlformats.org/officeDocument/2006/relationships">
   <c:date1904 val="0"/>
   <c:lang val="fr-FR"/>

</xml_diff>

<commit_message>
fit_to_height(): warn when a table can't be made to fit
flextable_dim() reports the forced height after height_all(), so it can't
tell whether the result actually fits. Judge from the natural (pre-force)
height instead: if padding-trimming isn't enough and rows have to be
compressed, warn that the table will still overflow in PowerPoint.

- new `warn` arg on fit_to_height() and full_width_table_slide() (default TRUE)
- tests for the warning and its suppression
- qmd notes the 15-row example is deliberately oversized

Co-Authored-By: Claude Sonnet 5 <noreply@anthropic.com>
</commit_message>
<xml_diff>
--- a/Example PowerPoint from functions.pptx
+++ b/Example PowerPoint from functions.pptx
@@ -125,7 +125,7 @@
 </p:presentation>
 </file>
 
-<file path=ppt/charts/chart2b3f6ff6a6ef.xml><?xml version="1.0" encoding="utf-8"?>
+<file path=ppt/charts/chart3416368b0c6f.xml><?xml version="1.0" encoding="utf-8"?>
 <c:chartSpace xmlns:c="http://schemas.openxmlformats.org/drawingml/2006/chart" xmlns:a="http://schemas.openxmlformats.org/drawingml/2006/main" xmlns:r="http://schemas.openxmlformats.org/officeDocument/2006/relationships">
   <c:date1904 val="0"/>
   <c:lang val="fr-FR"/>
@@ -502,7 +502,7 @@
 </c:chartSpace>
 </file>
 
-<file path=ppt/charts/chart2b3f78481caa.xml><?xml version="1.0" encoding="utf-8"?>
+<file path=ppt/charts/chart34167cc802a9.xml><?xml version="1.0" encoding="utf-8"?>
 <c:chartSpace xmlns:c="http://schemas.openxmlformats.org/drawingml/2006/chart" xmlns:a="http://schemas.openxmlformats.org/drawingml/2006/main" xmlns:r="http://schemas.openxmlformats.org/officeDocument/2006/relationships">
   <c:date1904 val="0"/>
   <c:lang val="fr-FR"/>

</xml_diff>